<commit_message>
feat: implement quiz builder functionality with backend integration and initial mobile app scaffolding
</commit_message>
<xml_diff>
--- a/docs/FIRST_REVIEW_FILLED.pptx
+++ b/docs/FIRST_REVIEW_FILLED.pptx
@@ -229,7 +229,7 @@
           <a:p>
             <a:fld id="{23456805-9FF0-4934-BDCD-CD6CD9C90D87}" type="datetimeFigureOut">
               <a:rPr lang="en-US" smtClean="0"/>
-              <a:t>6/5/2026</a:t>
+              <a:t>7/2/2026</a:t>
             </a:fld>
             <a:endParaRPr lang="en-US"/>
           </a:p>
@@ -625,7 +625,7 @@
           <a:p>
             <a:fld id="{94EB8EBC-5222-431C-84DD-DD60662C159C}" type="datetime3">
               <a:rPr lang="en-US" smtClean="0"/>
-              <a:t>5 June 2026</a:t>
+              <a:t>2 July 2026</a:t>
             </a:fld>
             <a:endParaRPr lang="en-US" dirty="0"/>
           </a:p>
@@ -800,7 +800,7 @@
           <a:p>
             <a:fld id="{098E28DC-53CF-4642-AB77-F3F3B8864F72}" type="datetime3">
               <a:rPr lang="en-US" smtClean="0"/>
-              <a:t>5 June 2026</a:t>
+              <a:t>2 July 2026</a:t>
             </a:fld>
             <a:endParaRPr lang="en-US" dirty="0"/>
           </a:p>
@@ -985,7 +985,7 @@
           <a:p>
             <a:fld id="{1967ACE5-42CA-4EDC-8760-DD2585F04707}" type="datetime3">
               <a:rPr lang="en-US" smtClean="0"/>
-              <a:t>5 June 2026</a:t>
+              <a:t>2 July 2026</a:t>
             </a:fld>
             <a:endParaRPr lang="en-US" dirty="0"/>
           </a:p>
@@ -1160,7 +1160,7 @@
           <a:p>
             <a:fld id="{2DB9DF8F-09D3-46AE-87C0-0E6AC09D07A6}" type="datetime3">
               <a:rPr lang="en-US" smtClean="0"/>
-              <a:t>5 June 2026</a:t>
+              <a:t>2 July 2026</a:t>
             </a:fld>
             <a:endParaRPr lang="en-US" dirty="0"/>
           </a:p>
@@ -1412,7 +1412,7 @@
           <a:p>
             <a:fld id="{5253FD35-0CB4-474A-9599-30C5D4C0E287}" type="datetime3">
               <a:rPr lang="en-US" smtClean="0"/>
-              <a:t>5 June 2026</a:t>
+              <a:t>2 July 2026</a:t>
             </a:fld>
             <a:endParaRPr lang="en-US" dirty="0"/>
           </a:p>
@@ -1648,7 +1648,7 @@
           <a:p>
             <a:fld id="{605DD382-1684-47A7-8447-FF64349E7EA4}" type="datetime3">
               <a:rPr lang="en-US" smtClean="0"/>
-              <a:t>5 June 2026</a:t>
+              <a:t>2 July 2026</a:t>
             </a:fld>
             <a:endParaRPr lang="en-US" dirty="0"/>
           </a:p>
@@ -2019,7 +2019,7 @@
           <a:p>
             <a:fld id="{10666D20-7225-440A-88E7-D6F958D48F89}" type="datetime3">
               <a:rPr lang="en-US" smtClean="0"/>
-              <a:t>5 June 2026</a:t>
+              <a:t>2 July 2026</a:t>
             </a:fld>
             <a:endParaRPr lang="en-US" dirty="0"/>
           </a:p>
@@ -2143,7 +2143,7 @@
           <a:p>
             <a:fld id="{81CB1683-EA87-4A2C-B387-AB50EB5CC6D6}" type="datetime3">
               <a:rPr lang="en-US" smtClean="0"/>
-              <a:t>5 June 2026</a:t>
+              <a:t>2 July 2026</a:t>
             </a:fld>
             <a:endParaRPr lang="en-US" dirty="0"/>
           </a:p>
@@ -2245,7 +2245,7 @@
           <a:p>
             <a:fld id="{56E2D354-87FD-45C8-B30B-40E925ADA766}" type="datetime3">
               <a:rPr lang="en-US" smtClean="0"/>
-              <a:t>5 June 2026</a:t>
+              <a:t>2 July 2026</a:t>
             </a:fld>
             <a:endParaRPr lang="en-US" dirty="0"/>
           </a:p>
@@ -2527,7 +2527,7 @@
           <a:p>
             <a:fld id="{236FCBC9-030E-4CA2-939A-297D2E5B0AF9}" type="datetime3">
               <a:rPr lang="en-US" smtClean="0"/>
-              <a:t>5 June 2026</a:t>
+              <a:t>2 July 2026</a:t>
             </a:fld>
             <a:endParaRPr lang="en-US" dirty="0"/>
           </a:p>
@@ -2786,7 +2786,7 @@
           <a:p>
             <a:fld id="{C5BC5EF5-3D0C-410F-81FA-0155F6DDC1A3}" type="datetime3">
               <a:rPr lang="en-US" smtClean="0"/>
-              <a:t>5 June 2026</a:t>
+              <a:t>2 July 2026</a:t>
             </a:fld>
             <a:endParaRPr lang="en-US" dirty="0"/>
           </a:p>
@@ -3007,7 +3007,7 @@
           <a:p>
             <a:fld id="{3EE8C92B-93F9-4684-984D-12FC30565B2E}" type="datetime3">
               <a:rPr lang="en-US" smtClean="0"/>
-              <a:t>5 June 2026</a:t>
+              <a:t>2 July 2026</a:t>
             </a:fld>
             <a:endParaRPr lang="en-US" dirty="0"/>
           </a:p>
@@ -3661,8 +3661,8 @@
         </p:nvSpPr>
         <p:spPr>
           <a:xfrm>
-            <a:off x="3055000" y="2373895"/>
-            <a:ext cx="3021867" cy="707886"/>
+            <a:off x="2991174" y="2373895"/>
+            <a:ext cx="3085694" cy="707886"/>
           </a:xfrm>
           <a:prstGeom prst="rect">
             <a:avLst/>
@@ -3683,7 +3683,7 @@
                 <a:latin typeface="Times New Roman" pitchFamily="18" charset="0"/>
                 <a:cs typeface="Times New Roman" pitchFamily="18" charset="0"/>
               </a:rPr>
-              <a:t>	    First Review</a:t>
+              <a:t>	    Second Review</a:t>
             </a:r>
           </a:p>
           <a:p>
@@ -3696,7 +3696,7 @@
                 <a:latin typeface="Times New Roman" pitchFamily="18" charset="0"/>
                 <a:cs typeface="Times New Roman" pitchFamily="18" charset="0"/>
               </a:rPr>
-              <a:t>Date: 5.6.2026  </a:t>
+              <a:t>   Date: 2.7.2026  </a:t>
             </a:r>
           </a:p>
         </p:txBody>
@@ -4041,7 +4041,7 @@
           <a:p>
             <a:fld id="{305CE664-CC6B-43B1-BCF8-14EAD95F037A}" type="datetime3">
               <a:rPr lang="en-US" smtClean="0"/>
-              <a:t>5 June 2026</a:t>
+              <a:t>2 July 2026</a:t>
             </a:fld>
             <a:endParaRPr lang="en-US" dirty="0"/>
           </a:p>
@@ -4069,7 +4069,7 @@
           <a:p>
             <a:r>
               <a:rPr lang="en-US" dirty="0"/>
-              <a:t>CYB23IN101 REVIEW - I</a:t>
+              <a:t>CYB23IN101 REVIEW - II</a:t>
             </a:r>
           </a:p>
         </p:txBody>
@@ -4205,7 +4205,7 @@
           <a:p>
             <a:fld id="{DE11E864-39B2-4D9A-938E-DF8E5B1FD578}" type="datetime3">
               <a:rPr lang="en-US" smtClean="0"/>
-              <a:t>5 June 2026</a:t>
+              <a:t>2 July 2026</a:t>
             </a:fld>
             <a:endParaRPr lang="en-US" dirty="0"/>
           </a:p>
@@ -4385,14 +4385,14 @@
           <p:nvPr>
             <p:extLst>
               <p:ext uri="{D42A27DB-BD31-4B8C-83A1-F6EECF244321}">
-                <p14:modId xmlns:p14="http://schemas.microsoft.com/office/powerpoint/2010/main" val="853865101"/>
+                <p14:modId xmlns:p14="http://schemas.microsoft.com/office/powerpoint/2010/main" val="3402253326"/>
               </p:ext>
             </p:extLst>
           </p:nvPr>
         </p:nvGraphicFramePr>
         <p:xfrm>
-          <a:off x="628651" y="565616"/>
-          <a:ext cx="8313218" cy="4214283"/>
+          <a:off x="628650" y="643109"/>
+          <a:ext cx="8313218" cy="3559607"/>
         </p:xfrm>
         <a:graphic>
           <a:graphicData uri="http://schemas.openxmlformats.org/drawingml/2006/table">
@@ -4437,7 +4437,7 @@
                   </a:extLst>
                 </a:gridCol>
               </a:tblGrid>
-              <a:tr h="591356">
+              <a:tr h="359207">
                 <a:tc>
                   <a:txBody>
                     <a:bodyPr/>
@@ -4465,11 +4465,11 @@
                     <a:bodyPr/>
                     <a:lstStyle/>
                     <a:p>
-                      <a:pPr algn="l">
+                      <a:pPr algn="ctr">
                         <a:buNone/>
                       </a:pPr>
                       <a:r>
-                        <a:rPr lang="en-IN" sz="1200" b="0">
+                        <a:rPr lang="en-IN" sz="1200" b="0" dirty="0">
                           <a:effectLst/>
                         </a:rPr>
                         <a:t>Modules</a:t>
@@ -4487,11 +4487,11 @@
                     <a:bodyPr/>
                     <a:lstStyle/>
                     <a:p>
-                      <a:pPr algn="l">
+                      <a:pPr algn="ctr">
                         <a:buNone/>
                       </a:pPr>
                       <a:r>
-                        <a:rPr lang="en-IN" sz="1200" b="0">
+                        <a:rPr lang="en-IN" sz="1200" b="0" dirty="0">
                           <a:effectLst/>
                         </a:rPr>
                         <a:t>Methodology / Algorithm</a:t>
@@ -4509,11 +4509,11 @@
                     <a:bodyPr/>
                     <a:lstStyle/>
                     <a:p>
-                      <a:pPr algn="l">
+                      <a:pPr algn="ctr">
                         <a:buNone/>
                       </a:pPr>
                       <a:r>
-                        <a:rPr lang="en-IN" sz="1200" b="0">
+                        <a:rPr lang="en-IN" sz="1200" b="0" dirty="0">
                           <a:effectLst/>
                         </a:rPr>
                         <a:t>Technologies (H/W and S/W)</a:t>
@@ -4531,11 +4531,11 @@
                     <a:bodyPr/>
                     <a:lstStyle/>
                     <a:p>
-                      <a:pPr algn="l">
+                      <a:pPr algn="ctr">
                         <a:buNone/>
                       </a:pPr>
                       <a:r>
-                        <a:rPr lang="en-IN" sz="1200" b="0">
+                        <a:rPr lang="en-IN" sz="1200" b="0" dirty="0">
                           <a:effectLst/>
                         </a:rPr>
                         <a:t>Implementation</a:t>
@@ -4554,7 +4554,7 @@
                   </a:ext>
                 </a:extLst>
               </a:tr>
-              <a:tr h="627446">
+              <a:tr h="388803">
                 <a:tc>
                   <a:txBody>
                     <a:bodyPr/>
@@ -4663,7 +4663,7 @@
                   </a:ext>
                 </a:extLst>
               </a:tr>
-              <a:tr h="724413">
+              <a:tr h="440029">
                 <a:tc>
                   <a:txBody>
                     <a:bodyPr/>
@@ -4796,7 +4796,7 @@
                   </a:ext>
                 </a:extLst>
               </a:tr>
-              <a:tr h="809608">
+              <a:tr h="491779">
                 <a:tc>
                   <a:txBody>
                     <a:bodyPr/>
@@ -4929,7 +4929,7 @@
                   </a:ext>
                 </a:extLst>
               </a:tr>
-              <a:tr h="724413">
+              <a:tr h="440029">
                 <a:tc>
                   <a:txBody>
                     <a:bodyPr/>
@@ -4939,7 +4939,7 @@
                         <a:buNone/>
                       </a:pPr>
                       <a:r>
-                        <a:rPr lang="en-IN" sz="1200">
+                        <a:rPr lang="en-IN" sz="1200" dirty="0">
                           <a:effectLst/>
                         </a:rPr>
                         <a:t>4</a:t>
@@ -5050,7 +5050,7 @@
                   </a:ext>
                 </a:extLst>
               </a:tr>
-              <a:tr h="724413">
+              <a:tr h="440029">
                 <a:tc>
                   <a:txBody>
                     <a:bodyPr/>
@@ -5180,7 +5180,7 @@
           <a:p>
             <a:fld id="{2B573973-4A1E-4C7C-AAB7-BDE9EAC7FD5C}" type="datetime3">
               <a:rPr lang="en-US" smtClean="0"/>
-              <a:t>5 June 2026</a:t>
+              <a:t>2 July 2026</a:t>
             </a:fld>
             <a:endParaRPr lang="en-US" dirty="0"/>
           </a:p>
@@ -5208,7 +5208,7 @@
           <a:p>
             <a:r>
               <a:rPr lang="en-US" dirty="0"/>
-              <a:t>CYB23IN101 REVIEW - I</a:t>
+              <a:t>CYB23IN101 REVIEW - II</a:t>
             </a:r>
           </a:p>
         </p:txBody>
@@ -5813,7 +5813,7 @@
               </a:spcAft>
             </a:pPr>
             <a:r>
-              <a:rPr lang="en-US" sz="800" kern="1200">
+              <a:rPr lang="en-US" sz="800" kern="1200" dirty="0">
                 <a:solidFill>
                   <a:srgbClr val="FFFFFF"/>
                 </a:solidFill>
@@ -5821,7 +5821,7 @@
                 <a:ea typeface="+mn-ea"/>
                 <a:cs typeface="+mn-cs"/>
               </a:rPr>
-              <a:t>CYB23IN101 REVIEW - I</a:t>
+              <a:t>CYB23IN101 REVIEW - II</a:t>
             </a:r>
           </a:p>
         </p:txBody>
@@ -5957,7 +5957,7 @@
                   <a:spcPts val="600"/>
                 </a:spcAft>
               </a:pPr>
-              <a:t>5 June 2026</a:t>
+              <a:t>2 July 2026</a:t>
             </a:fld>
             <a:endParaRPr lang="en-US" sz="800">
               <a:solidFill>
@@ -6142,7 +6142,7 @@
         <p:spPr>
           <a:xfrm>
             <a:off x="191068" y="893929"/>
-            <a:ext cx="8746177" cy="1077218"/>
+            <a:ext cx="8746177" cy="1815882"/>
           </a:xfrm>
           <a:prstGeom prst="rect">
             <a:avLst/>
@@ -6190,7 +6190,34 @@
                 <a:latin typeface="Times New Roman" pitchFamily="18" charset="0"/>
                 <a:cs typeface="Times New Roman" pitchFamily="18" charset="0"/>
               </a:rPr>
-              <a:t>Most Literature Review are summarized and identified the gaps and key findings with the help of AI</a:t>
+              <a:t>6 JUNE – 21 JUNE: Building a Production  Ready </a:t>
+            </a:r>
+            <a:r>
+              <a:rPr lang="en-GB" sz="1600" dirty="0" err="1">
+                <a:latin typeface="Times New Roman" pitchFamily="18" charset="0"/>
+                <a:cs typeface="Times New Roman" pitchFamily="18" charset="0"/>
+              </a:rPr>
+              <a:t>Weebsite</a:t>
+            </a:r>
+            <a:r>
+              <a:rPr lang="en-GB" sz="1600" dirty="0">
+                <a:latin typeface="Times New Roman" pitchFamily="18" charset="0"/>
+                <a:cs typeface="Times New Roman" pitchFamily="18" charset="0"/>
+              </a:rPr>
+              <a:t> for Data Collection</a:t>
+            </a:r>
+          </a:p>
+          <a:p>
+            <a:pPr marL="285750" indent="-285750">
+              <a:buFont typeface="Arial" panose="020B0604020202020204" pitchFamily="34" charset="0"/>
+              <a:buChar char="•"/>
+            </a:pPr>
+            <a:r>
+              <a:rPr lang="en-GB" sz="1600" dirty="0">
+                <a:latin typeface="Times New Roman" pitchFamily="18" charset="0"/>
+                <a:cs typeface="Times New Roman" pitchFamily="18" charset="0"/>
+              </a:rPr>
+              <a:t>23 JUNE – 1 JULY : Building a handheld App for Multi Disciplines</a:t>
             </a:r>
           </a:p>
           <a:p>
@@ -6203,6 +6230,29 @@
               <a:cs typeface="Times New Roman" pitchFamily="18" charset="0"/>
             </a:endParaRPr>
           </a:p>
+          <a:p>
+            <a:pPr marL="285750" indent="-285750">
+              <a:buFont typeface="Arial" panose="020B0604020202020204" pitchFamily="34" charset="0"/>
+              <a:buChar char="•"/>
+            </a:pPr>
+            <a:r>
+              <a:rPr lang="en-GB" sz="1600" dirty="0">
+                <a:latin typeface="Times New Roman" pitchFamily="18" charset="0"/>
+                <a:cs typeface="Times New Roman" pitchFamily="18" charset="0"/>
+              </a:rPr>
+              <a:t>Most Literature Review are summarized and identified the gaps and key findings with the help of AI</a:t>
+            </a:r>
+          </a:p>
+          <a:p>
+            <a:pPr marL="285750" indent="-285750">
+              <a:buFont typeface="Arial" panose="020B0604020202020204" pitchFamily="34" charset="0"/>
+              <a:buChar char="•"/>
+            </a:pPr>
+            <a:endParaRPr lang="en-GB" sz="1600" dirty="0">
+              <a:latin typeface="Times New Roman" pitchFamily="18" charset="0"/>
+              <a:cs typeface="Times New Roman" pitchFamily="18" charset="0"/>
+            </a:endParaRPr>
+          </a:p>
         </p:txBody>
       </p:sp>
       <p:sp>
@@ -6222,7 +6272,7 @@
           <a:p>
             <a:fld id="{2FFD4BED-E319-4DA0-96BF-17657C6E3A60}" type="datetime3">
               <a:rPr lang="en-US" smtClean="0"/>
-              <a:t>5 June 2026</a:t>
+              <a:t>2 July 2026</a:t>
             </a:fld>
             <a:endParaRPr lang="en-US" dirty="0"/>
           </a:p>
@@ -6249,10 +6299,9 @@
           <a:lstStyle/>
           <a:p>
             <a:r>
-              <a:rPr lang="en-US"/>
-              <a:t>CYB23IN101 REVIEW - I</a:t>
-            </a:r>
-            <a:endParaRPr lang="en-US" dirty="0"/>
+              <a:rPr lang="en-US" dirty="0"/>
+              <a:t>CYB23IN101 REVIEW - II</a:t>
+            </a:r>
           </a:p>
         </p:txBody>
       </p:sp>
@@ -6742,7 +6791,7 @@
           <a:p>
             <a:fld id="{756D0CD2-9846-482E-BF67-7C2753030DC2}" type="datetime3">
               <a:rPr lang="en-US" smtClean="0"/>
-              <a:t>5 June 2026</a:t>
+              <a:t>2 July 2026</a:t>
             </a:fld>
             <a:endParaRPr lang="en-US" dirty="0"/>
           </a:p>
@@ -6770,7 +6819,7 @@
           <a:p>
             <a:r>
               <a:rPr lang="en-US" dirty="0"/>
-              <a:t>CYB23IN301 REVIEW - I</a:t>
+              <a:t>CYB23IN301 REVIEW - II</a:t>
             </a:r>
           </a:p>
         </p:txBody>
@@ -7161,7 +7210,7 @@
           <a:p>
             <a:fld id="{24A434A4-5EBF-4C57-A471-F9649EE16CF8}" type="datetime3">
               <a:rPr lang="en-US" smtClean="0"/>
-              <a:t>5 June 2026</a:t>
+              <a:t>2 July 2026</a:t>
             </a:fld>
             <a:endParaRPr lang="en-US" dirty="0"/>
           </a:p>
@@ -7184,7 +7233,7 @@
           <a:p>
             <a:r>
               <a:rPr lang="en-US" dirty="0"/>
-              <a:t>CYB23IN101 REVIEW - I</a:t>
+              <a:t>CYB23IN101 REVIEW - II</a:t>
             </a:r>
           </a:p>
         </p:txBody>
@@ -7305,7 +7354,7 @@
           <a:p>
             <a:fld id="{F6B04E1E-CF05-4B41-8802-CD685CA27131}" type="datetime3">
               <a:rPr lang="en-US" smtClean="0"/>
-              <a:t>5 June 2026</a:t>
+              <a:t>2 July 2026</a:t>
             </a:fld>
             <a:endParaRPr lang="en-US" dirty="0"/>
           </a:p>
@@ -7328,7 +7377,7 @@
           <a:p>
             <a:r>
               <a:rPr lang="en-US" dirty="0"/>
-              <a:t>CYB23IN101 REVIEW - I</a:t>
+              <a:t>CYB23IN101 REVIEW - II</a:t>
             </a:r>
           </a:p>
         </p:txBody>
@@ -7666,7 +7715,7 @@
           <a:p>
             <a:fld id="{E019806D-BBF9-4065-82F1-BB4B2025BF7F}" type="datetime3">
               <a:rPr lang="en-US" smtClean="0"/>
-              <a:t>5 June 2026</a:t>
+              <a:t>2 July 2026</a:t>
             </a:fld>
             <a:endParaRPr lang="en-US" dirty="0"/>
           </a:p>
@@ -7694,7 +7743,7 @@
           <a:p>
             <a:r>
               <a:rPr lang="en-US" dirty="0"/>
-              <a:t>CYB23IN101 REVIEW - I</a:t>
+              <a:t>CYB23IN101 REVIEW – II</a:t>
             </a:r>
           </a:p>
         </p:txBody>
@@ -7755,7 +7804,7 @@
           <a:p>
             <a:fld id="{2DB9DF8F-09D3-46AE-87C0-0E6AC09D07A6}" type="datetime3">
               <a:rPr lang="en-US" smtClean="0"/>
-              <a:t>5 June 2026</a:t>
+              <a:t>2 July 2026</a:t>
             </a:fld>
             <a:endParaRPr lang="en-US" dirty="0"/>
           </a:p>
@@ -7783,10 +7832,9 @@
           <a:lstStyle/>
           <a:p>
             <a:r>
-              <a:rPr lang="en-US"/>
-              <a:t>INT500 REVIEW - I</a:t>
-            </a:r>
-            <a:endParaRPr lang="en-US" dirty="0"/>
+              <a:rPr lang="en-US" dirty="0"/>
+              <a:t>INT500 REVIEW - II</a:t>
+            </a:r>
           </a:p>
         </p:txBody>
       </p:sp>
@@ -9275,7 +9323,7 @@
           <a:p>
             <a:fld id="{4E2F8081-A97F-4DB5-8CE1-E687C3C2B1EA}" type="datetime3">
               <a:rPr lang="en-US" smtClean="0"/>
-              <a:t>5 June 2026</a:t>
+              <a:t>2 July 2026</a:t>
             </a:fld>
             <a:endParaRPr lang="en-US" dirty="0"/>
           </a:p>
@@ -9303,7 +9351,7 @@
           <a:p>
             <a:r>
               <a:rPr lang="en-US" dirty="0"/>
-              <a:t>CYB23IN101 REVIEW - I</a:t>
+              <a:t>CYB23IN101 REVIEW - II</a:t>
             </a:r>
           </a:p>
         </p:txBody>
@@ -10608,7 +10656,7 @@
           <a:p>
             <a:fld id="{79B8DED3-A3EE-40F6-BF5C-4608A21E219C}" type="datetime3">
               <a:rPr lang="en-US" smtClean="0"/>
-              <a:t>5 June 2026</a:t>
+              <a:t>2 July 2026</a:t>
             </a:fld>
             <a:endParaRPr lang="en-US" dirty="0"/>
           </a:p>
@@ -10636,7 +10684,7 @@
           <a:p>
             <a:r>
               <a:rPr lang="en-US" dirty="0"/>
-              <a:t>CYB23IN101 REVIEW - I</a:t>
+              <a:t>CYB23IN101 REVIEW - II</a:t>
             </a:r>
           </a:p>
         </p:txBody>
@@ -10745,7 +10793,7 @@
           <a:p>
             <a:fld id="{2DB9DF8F-09D3-46AE-87C0-0E6AC09D07A6}" type="datetime3">
               <a:rPr lang="en-US" smtClean="0"/>
-              <a:t>5 June 2026</a:t>
+              <a:t>2 July 2026</a:t>
             </a:fld>
             <a:endParaRPr lang="en-US" dirty="0"/>
           </a:p>
@@ -10773,10 +10821,9 @@
           <a:lstStyle/>
           <a:p>
             <a:r>
-              <a:rPr lang="en-US"/>
-              <a:t>INT500 REVIEW - I</a:t>
-            </a:r>
-            <a:endParaRPr lang="en-US" dirty="0"/>
+              <a:rPr lang="en-US" dirty="0"/>
+              <a:t>INT500 REVIEW - II</a:t>
+            </a:r>
           </a:p>
         </p:txBody>
       </p:sp>
@@ -12671,7 +12718,7 @@
           <a:p>
             <a:fld id="{A677CD66-4046-4467-BD12-ED7F3687165D}" type="datetime3">
               <a:rPr lang="en-US" smtClean="0"/>
-              <a:t>5 June 2026</a:t>
+              <a:t>2 July 2026</a:t>
             </a:fld>
             <a:endParaRPr lang="en-US" dirty="0"/>
           </a:p>
@@ -12699,7 +12746,7 @@
           <a:p>
             <a:r>
               <a:rPr lang="en-US" dirty="0"/>
-              <a:t>CYB23IN101 REVIEW - I</a:t>
+              <a:t>CYB23IN101 REVIEW - II</a:t>
             </a:r>
           </a:p>
         </p:txBody>
@@ -12765,7 +12812,7 @@
           <a:p>
             <a:fld id="{2DB9DF8F-09D3-46AE-87C0-0E6AC09D07A6}" type="datetime3">
               <a:rPr lang="en-US" smtClean="0"/>
-              <a:t>5 June 2026</a:t>
+              <a:t>2 July 2026</a:t>
             </a:fld>
             <a:endParaRPr lang="en-US" dirty="0"/>
           </a:p>
@@ -12793,10 +12840,9 @@
           <a:lstStyle/>
           <a:p>
             <a:r>
-              <a:rPr lang="en-US"/>
-              <a:t>INT500 REVIEW - I</a:t>
-            </a:r>
-            <a:endParaRPr lang="en-US" dirty="0"/>
+              <a:rPr lang="en-US" dirty="0"/>
+              <a:t>INT500 REVIEW - II</a:t>
+            </a:r>
           </a:p>
         </p:txBody>
       </p:sp>
@@ -14049,7 +14095,7 @@
           <a:p>
             <a:fld id="{5A880E69-CE3A-4D4E-8C11-95F4E85341CB}" type="datetime3">
               <a:rPr lang="en-US" smtClean="0"/>
-              <a:t>5 June 2026</a:t>
+              <a:t>2 July 2026</a:t>
             </a:fld>
             <a:endParaRPr lang="en-US" dirty="0"/>
           </a:p>

</xml_diff>